<commit_message>
Ensure appendix tables retain compact native line spacing
</commit_message>
<xml_diff>
--- a/Submission_Pack/Layout_Only_2026-10-06/COMP2501_presentation_RQ1-4_2026-10-06_LAYOUT_OPTIMIZED.pptx
+++ b/Submission_Pack/Layout_Only_2026-10-06/COMP2501_presentation_RQ1-4_2026-10-06_LAYOUT_OPTIMIZED.pptx
@@ -12175,6 +12175,11 @@
                     <a:bodyPr/>
                     <a:lstStyle/>
                     <a:p>
+                      <a:pPr>
+                        <a:lnSpc>
+                          <a:spcPct val="100000"/>
+                        </a:lnSpc>
+                      </a:pPr>
                       <a:r>
                         <a:rPr sz="1500" b="1">
                           <a:solidFill>
@@ -12199,6 +12204,11 @@
                     <a:bodyPr/>
                     <a:lstStyle/>
                     <a:p>
+                      <a:pPr>
+                        <a:lnSpc>
+                          <a:spcPct val="100000"/>
+                        </a:lnSpc>
+                      </a:pPr>
                       <a:r>
                         <a:rPr sz="1500" b="1">
                           <a:solidFill>
@@ -12223,6 +12233,11 @@
                     <a:bodyPr/>
                     <a:lstStyle/>
                     <a:p>
+                      <a:pPr>
+                        <a:lnSpc>
+                          <a:spcPct val="100000"/>
+                        </a:lnSpc>
+                      </a:pPr>
                       <a:r>
                         <a:rPr sz="1500" b="1">
                           <a:solidFill>
@@ -12249,6 +12264,11 @@
                     <a:bodyPr/>
                     <a:lstStyle/>
                     <a:p>
+                      <a:pPr>
+                        <a:lnSpc>
+                          <a:spcPct val="100000"/>
+                        </a:lnSpc>
+                      </a:pPr>
                       <a:r>
                         <a:rPr sz="1400">
                           <a:solidFill>
@@ -12273,6 +12293,11 @@
                     <a:bodyPr/>
                     <a:lstStyle/>
                     <a:p>
+                      <a:pPr>
+                        <a:lnSpc>
+                          <a:spcPct val="100000"/>
+                        </a:lnSpc>
+                      </a:pPr>
                       <a:r>
                         <a:rPr sz="1400">
                           <a:solidFill>
@@ -12297,6 +12322,11 @@
                     <a:bodyPr/>
                     <a:lstStyle/>
                     <a:p>
+                      <a:pPr>
+                        <a:lnSpc>
+                          <a:spcPct val="100000"/>
+                        </a:lnSpc>
+                      </a:pPr>
                       <a:r>
                         <a:rPr sz="1400">
                           <a:solidFill>
@@ -12323,6 +12353,11 @@
                     <a:bodyPr/>
                     <a:lstStyle/>
                     <a:p>
+                      <a:pPr>
+                        <a:lnSpc>
+                          <a:spcPct val="100000"/>
+                        </a:lnSpc>
+                      </a:pPr>
                       <a:r>
                         <a:rPr sz="1400">
                           <a:solidFill>
@@ -12347,6 +12382,11 @@
                     <a:bodyPr/>
                     <a:lstStyle/>
                     <a:p>
+                      <a:pPr>
+                        <a:lnSpc>
+                          <a:spcPct val="100000"/>
+                        </a:lnSpc>
+                      </a:pPr>
                       <a:r>
                         <a:rPr sz="1400">
                           <a:solidFill>
@@ -12371,6 +12411,11 @@
                     <a:bodyPr/>
                     <a:lstStyle/>
                     <a:p>
+                      <a:pPr>
+                        <a:lnSpc>
+                          <a:spcPct val="100000"/>
+                        </a:lnSpc>
+                      </a:pPr>
                       <a:r>
                         <a:rPr sz="1400">
                           <a:solidFill>
@@ -12397,6 +12442,11 @@
                     <a:bodyPr/>
                     <a:lstStyle/>
                     <a:p>
+                      <a:pPr>
+                        <a:lnSpc>
+                          <a:spcPct val="100000"/>
+                        </a:lnSpc>
+                      </a:pPr>
                       <a:r>
                         <a:rPr sz="1400">
                           <a:solidFill>
@@ -12421,6 +12471,11 @@
                     <a:bodyPr/>
                     <a:lstStyle/>
                     <a:p>
+                      <a:pPr>
+                        <a:lnSpc>
+                          <a:spcPct val="100000"/>
+                        </a:lnSpc>
+                      </a:pPr>
                       <a:r>
                         <a:rPr sz="1400">
                           <a:solidFill>
@@ -12445,6 +12500,11 @@
                     <a:bodyPr/>
                     <a:lstStyle/>
                     <a:p>
+                      <a:pPr>
+                        <a:lnSpc>
+                          <a:spcPct val="100000"/>
+                        </a:lnSpc>
+                      </a:pPr>
                       <a:r>
                         <a:rPr sz="1400">
                           <a:solidFill>
@@ -12471,6 +12531,11 @@
                     <a:bodyPr/>
                     <a:lstStyle/>
                     <a:p>
+                      <a:pPr>
+                        <a:lnSpc>
+                          <a:spcPct val="100000"/>
+                        </a:lnSpc>
+                      </a:pPr>
                       <a:r>
                         <a:rPr sz="1400">
                           <a:solidFill>
@@ -12495,6 +12560,11 @@
                     <a:bodyPr/>
                     <a:lstStyle/>
                     <a:p>
+                      <a:pPr>
+                        <a:lnSpc>
+                          <a:spcPct val="100000"/>
+                        </a:lnSpc>
+                      </a:pPr>
                       <a:r>
                         <a:rPr sz="1400">
                           <a:solidFill>
@@ -12519,6 +12589,11 @@
                     <a:bodyPr/>
                     <a:lstStyle/>
                     <a:p>
+                      <a:pPr>
+                        <a:lnSpc>
+                          <a:spcPct val="100000"/>
+                        </a:lnSpc>
+                      </a:pPr>
                       <a:r>
                         <a:rPr sz="1400">
                           <a:solidFill>
@@ -12545,6 +12620,11 @@
                     <a:bodyPr/>
                     <a:lstStyle/>
                     <a:p>
+                      <a:pPr>
+                        <a:lnSpc>
+                          <a:spcPct val="100000"/>
+                        </a:lnSpc>
+                      </a:pPr>
                       <a:r>
                         <a:rPr sz="1400">
                           <a:solidFill>
@@ -12569,6 +12649,11 @@
                     <a:bodyPr/>
                     <a:lstStyle/>
                     <a:p>
+                      <a:pPr>
+                        <a:lnSpc>
+                          <a:spcPct val="100000"/>
+                        </a:lnSpc>
+                      </a:pPr>
                       <a:r>
                         <a:rPr sz="1400">
                           <a:solidFill>
@@ -12593,6 +12678,11 @@
                     <a:bodyPr/>
                     <a:lstStyle/>
                     <a:p>
+                      <a:pPr>
+                        <a:lnSpc>
+                          <a:spcPct val="100000"/>
+                        </a:lnSpc>
+                      </a:pPr>
                       <a:r>
                         <a:rPr sz="1400">
                           <a:solidFill>
@@ -12619,6 +12709,11 @@
                     <a:bodyPr/>
                     <a:lstStyle/>
                     <a:p>
+                      <a:pPr>
+                        <a:lnSpc>
+                          <a:spcPct val="100000"/>
+                        </a:lnSpc>
+                      </a:pPr>
                       <a:r>
                         <a:rPr sz="1400">
                           <a:solidFill>
@@ -12643,6 +12738,11 @@
                     <a:bodyPr/>
                     <a:lstStyle/>
                     <a:p>
+                      <a:pPr>
+                        <a:lnSpc>
+                          <a:spcPct val="100000"/>
+                        </a:lnSpc>
+                      </a:pPr>
                       <a:r>
                         <a:rPr sz="1400">
                           <a:solidFill>
@@ -12667,6 +12767,11 @@
                     <a:bodyPr/>
                     <a:lstStyle/>
                     <a:p>
+                      <a:pPr>
+                        <a:lnSpc>
+                          <a:spcPct val="100000"/>
+                        </a:lnSpc>
+                      </a:pPr>
                       <a:r>
                         <a:rPr sz="1400">
                           <a:solidFill>
@@ -12693,6 +12798,11 @@
                     <a:bodyPr/>
                     <a:lstStyle/>
                     <a:p>
+                      <a:pPr>
+                        <a:lnSpc>
+                          <a:spcPct val="100000"/>
+                        </a:lnSpc>
+                      </a:pPr>
                       <a:r>
                         <a:rPr sz="1400">
                           <a:solidFill>
@@ -12717,6 +12827,11 @@
                     <a:bodyPr/>
                     <a:lstStyle/>
                     <a:p>
+                      <a:pPr>
+                        <a:lnSpc>
+                          <a:spcPct val="100000"/>
+                        </a:lnSpc>
+                      </a:pPr>
                       <a:r>
                         <a:rPr sz="1400">
                           <a:solidFill>
@@ -12741,6 +12856,11 @@
                     <a:bodyPr/>
                     <a:lstStyle/>
                     <a:p>
+                      <a:pPr>
+                        <a:lnSpc>
+                          <a:spcPct val="100000"/>
+                        </a:lnSpc>
+                      </a:pPr>
                       <a:r>
                         <a:rPr sz="1400">
                           <a:solidFill>
@@ -12767,6 +12887,11 @@
                     <a:bodyPr/>
                     <a:lstStyle/>
                     <a:p>
+                      <a:pPr>
+                        <a:lnSpc>
+                          <a:spcPct val="100000"/>
+                        </a:lnSpc>
+                      </a:pPr>
                       <a:r>
                         <a:rPr sz="1400">
                           <a:solidFill>
@@ -12791,6 +12916,11 @@
                     <a:bodyPr/>
                     <a:lstStyle/>
                     <a:p>
+                      <a:pPr>
+                        <a:lnSpc>
+                          <a:spcPct val="100000"/>
+                        </a:lnSpc>
+                      </a:pPr>
                       <a:r>
                         <a:rPr sz="1400">
                           <a:solidFill>
@@ -12815,6 +12945,11 @@
                     <a:bodyPr/>
                     <a:lstStyle/>
                     <a:p>
+                      <a:pPr>
+                        <a:lnSpc>
+                          <a:spcPct val="100000"/>
+                        </a:lnSpc>
+                      </a:pPr>
                       <a:r>
                         <a:rPr sz="1400">
                           <a:solidFill>
@@ -13532,6 +13667,11 @@
                     <a:bodyPr/>
                     <a:lstStyle/>
                     <a:p>
+                      <a:pPr>
+                        <a:lnSpc>
+                          <a:spcPct val="100000"/>
+                        </a:lnSpc>
+                      </a:pPr>
                       <a:r>
                         <a:rPr sz="1600" b="1">
                           <a:solidFill>
@@ -13556,6 +13696,11 @@
                     <a:bodyPr/>
                     <a:lstStyle/>
                     <a:p>
+                      <a:pPr>
+                        <a:lnSpc>
+                          <a:spcPct val="100000"/>
+                        </a:lnSpc>
+                      </a:pPr>
                       <a:r>
                         <a:rPr sz="1600" b="1">
                           <a:solidFill>
@@ -13580,6 +13725,11 @@
                     <a:bodyPr/>
                     <a:lstStyle/>
                     <a:p>
+                      <a:pPr>
+                        <a:lnSpc>
+                          <a:spcPct val="100000"/>
+                        </a:lnSpc>
+                      </a:pPr>
                       <a:r>
                         <a:rPr sz="1600" b="1">
                           <a:solidFill>
@@ -13604,6 +13754,11 @@
                     <a:bodyPr/>
                     <a:lstStyle/>
                     <a:p>
+                      <a:pPr>
+                        <a:lnSpc>
+                          <a:spcPct val="100000"/>
+                        </a:lnSpc>
+                      </a:pPr>
                       <a:r>
                         <a:rPr sz="1600" b="1">
                           <a:solidFill>
@@ -13630,6 +13785,11 @@
                     <a:bodyPr/>
                     <a:lstStyle/>
                     <a:p>
+                      <a:pPr>
+                        <a:lnSpc>
+                          <a:spcPct val="100000"/>
+                        </a:lnSpc>
+                      </a:pPr>
                       <a:r>
                         <a:rPr sz="1600">
                           <a:solidFill>
@@ -13654,6 +13814,11 @@
                     <a:bodyPr/>
                     <a:lstStyle/>
                     <a:p>
+                      <a:pPr>
+                        <a:lnSpc>
+                          <a:spcPct val="100000"/>
+                        </a:lnSpc>
+                      </a:pPr>
                       <a:r>
                         <a:rPr sz="1600">
                           <a:solidFill>
@@ -13678,6 +13843,11 @@
                     <a:bodyPr/>
                     <a:lstStyle/>
                     <a:p>
+                      <a:pPr>
+                        <a:lnSpc>
+                          <a:spcPct val="100000"/>
+                        </a:lnSpc>
+                      </a:pPr>
                       <a:r>
                         <a:rPr sz="1600">
                           <a:solidFill>
@@ -13702,6 +13872,11 @@
                     <a:bodyPr/>
                     <a:lstStyle/>
                     <a:p>
+                      <a:pPr>
+                        <a:lnSpc>
+                          <a:spcPct val="100000"/>
+                        </a:lnSpc>
+                      </a:pPr>
                       <a:r>
                         <a:rPr sz="1600">
                           <a:solidFill>
@@ -13728,6 +13903,11 @@
                     <a:bodyPr/>
                     <a:lstStyle/>
                     <a:p>
+                      <a:pPr>
+                        <a:lnSpc>
+                          <a:spcPct val="100000"/>
+                        </a:lnSpc>
+                      </a:pPr>
                       <a:r>
                         <a:rPr sz="1600">
                           <a:solidFill>
@@ -13752,6 +13932,11 @@
                     <a:bodyPr/>
                     <a:lstStyle/>
                     <a:p>
+                      <a:pPr>
+                        <a:lnSpc>
+                          <a:spcPct val="100000"/>
+                        </a:lnSpc>
+                      </a:pPr>
                       <a:r>
                         <a:rPr sz="1600">
                           <a:solidFill>
@@ -13776,6 +13961,11 @@
                     <a:bodyPr/>
                     <a:lstStyle/>
                     <a:p>
+                      <a:pPr>
+                        <a:lnSpc>
+                          <a:spcPct val="100000"/>
+                        </a:lnSpc>
+                      </a:pPr>
                       <a:r>
                         <a:rPr sz="1600">
                           <a:solidFill>
@@ -13800,6 +13990,11 @@
                     <a:bodyPr/>
                     <a:lstStyle/>
                     <a:p>
+                      <a:pPr>
+                        <a:lnSpc>
+                          <a:spcPct val="100000"/>
+                        </a:lnSpc>
+                      </a:pPr>
                       <a:r>
                         <a:rPr sz="1600">
                           <a:solidFill>
@@ -13826,6 +14021,11 @@
                     <a:bodyPr/>
                     <a:lstStyle/>
                     <a:p>
+                      <a:pPr>
+                        <a:lnSpc>
+                          <a:spcPct val="100000"/>
+                        </a:lnSpc>
+                      </a:pPr>
                       <a:r>
                         <a:rPr sz="1600">
                           <a:solidFill>
@@ -13850,6 +14050,11 @@
                     <a:bodyPr/>
                     <a:lstStyle/>
                     <a:p>
+                      <a:pPr>
+                        <a:lnSpc>
+                          <a:spcPct val="100000"/>
+                        </a:lnSpc>
+                      </a:pPr>
                       <a:r>
                         <a:rPr sz="1600">
                           <a:solidFill>
@@ -13874,6 +14079,11 @@
                     <a:bodyPr/>
                     <a:lstStyle/>
                     <a:p>
+                      <a:pPr>
+                        <a:lnSpc>
+                          <a:spcPct val="100000"/>
+                        </a:lnSpc>
+                      </a:pPr>
                       <a:r>
                         <a:rPr sz="1600">
                           <a:solidFill>
@@ -13898,6 +14108,11 @@
                     <a:bodyPr/>
                     <a:lstStyle/>
                     <a:p>
+                      <a:pPr>
+                        <a:lnSpc>
+                          <a:spcPct val="100000"/>
+                        </a:lnSpc>
+                      </a:pPr>
                       <a:r>
                         <a:rPr sz="1600">
                           <a:solidFill>
@@ -13924,6 +14139,11 @@
                     <a:bodyPr/>
                     <a:lstStyle/>
                     <a:p>
+                      <a:pPr>
+                        <a:lnSpc>
+                          <a:spcPct val="100000"/>
+                        </a:lnSpc>
+                      </a:pPr>
                       <a:r>
                         <a:rPr sz="1600">
                           <a:solidFill>
@@ -13948,6 +14168,11 @@
                     <a:bodyPr/>
                     <a:lstStyle/>
                     <a:p>
+                      <a:pPr>
+                        <a:lnSpc>
+                          <a:spcPct val="100000"/>
+                        </a:lnSpc>
+                      </a:pPr>
                       <a:r>
                         <a:rPr sz="1600">
                           <a:solidFill>
@@ -13972,6 +14197,11 @@
                     <a:bodyPr/>
                     <a:lstStyle/>
                     <a:p>
+                      <a:pPr>
+                        <a:lnSpc>
+                          <a:spcPct val="100000"/>
+                        </a:lnSpc>
+                      </a:pPr>
                       <a:r>
                         <a:rPr sz="1600">
                           <a:solidFill>
@@ -13996,6 +14226,11 @@
                     <a:bodyPr/>
                     <a:lstStyle/>
                     <a:p>
+                      <a:pPr>
+                        <a:lnSpc>
+                          <a:spcPct val="100000"/>
+                        </a:lnSpc>
+                      </a:pPr>
                       <a:r>
                         <a:rPr sz="1600">
                           <a:solidFill>
@@ -14009,6 +14244,11 @@
                       </a:r>
                     </a:p>
                     <a:p>
+                      <a:pPr>
+                        <a:lnSpc>
+                          <a:spcPct val="100000"/>
+                        </a:lnSpc>
+                      </a:pPr>
                       <a:r>
                         <a:rPr sz="1600">
                           <a:solidFill>
@@ -14035,6 +14275,11 @@
                     <a:bodyPr/>
                     <a:lstStyle/>
                     <a:p>
+                      <a:pPr>
+                        <a:lnSpc>
+                          <a:spcPct val="100000"/>
+                        </a:lnSpc>
+                      </a:pPr>
                       <a:r>
                         <a:rPr sz="1600">
                           <a:solidFill>
@@ -14059,6 +14304,11 @@
                     <a:bodyPr/>
                     <a:lstStyle/>
                     <a:p>
+                      <a:pPr>
+                        <a:lnSpc>
+                          <a:spcPct val="100000"/>
+                        </a:lnSpc>
+                      </a:pPr>
                       <a:r>
                         <a:rPr sz="1600">
                           <a:solidFill>
@@ -14083,6 +14333,11 @@
                     <a:bodyPr/>
                     <a:lstStyle/>
                     <a:p>
+                      <a:pPr>
+                        <a:lnSpc>
+                          <a:spcPct val="100000"/>
+                        </a:lnSpc>
+                      </a:pPr>
                       <a:r>
                         <a:rPr sz="1600">
                           <a:solidFill>
@@ -14107,6 +14362,11 @@
                     <a:bodyPr/>
                     <a:lstStyle/>
                     <a:p>
+                      <a:pPr>
+                        <a:lnSpc>
+                          <a:spcPct val="100000"/>
+                        </a:lnSpc>
+                      </a:pPr>
                       <a:r>
                         <a:rPr sz="1600">
                           <a:solidFill>
@@ -14120,6 +14380,11 @@
                       </a:r>
                     </a:p>
                     <a:p>
+                      <a:pPr>
+                        <a:lnSpc>
+                          <a:spcPct val="100000"/>
+                        </a:lnSpc>
+                      </a:pPr>
                       <a:r>
                         <a:rPr sz="1600">
                           <a:solidFill>

</xml_diff>